<commit_message>
feat: add team member names to presentation slides, PDF, and PPTX
</commit_message>
<xml_diff>
--- a/WeatherGPT_SIH2026_Presentation.pptx
+++ b/WeatherGPT_SIH2026_Presentation.pptx
@@ -2038,8 +2038,8 @@
         </p:nvSpPr>
         <p:spPr>
           <a:xfrm>
-            <a:off x="914400" y="2560320"/>
-            <a:ext cx="10058400" cy="914400"/>
+            <a:off x="914400" y="2468880"/>
+            <a:ext cx="10058400" cy="640080"/>
           </a:xfrm>
           <a:prstGeom prst="rect">
             <a:avLst/>
@@ -2053,12 +2053,12 @@
           <a:p>
             <a:pPr indent="0" marL="0">
               <a:lnSpc>
-                <a:spcPct val="120000"/>
+                <a:spcPct val="115000"/>
               </a:lnSpc>
               <a:buNone/>
             </a:pPr>
             <a:r>
-              <a:rPr lang="en-US" sz="1300" dirty="0">
+              <a:rPr lang="en-US" sz="1250" dirty="0">
                 <a:solidFill>
                   <a:srgbClr val="E2E8F0"/>
                 </a:solidFill>
@@ -2068,13 +2068,52 @@
               </a:rPr>
               <a:t>An intelligent conversational platform that integrates meteorological datasets, numerical weather prediction (GFS/WRF) models, and CAP v1.2 disaster warning systems into accessible natural language &amp; regional voice for 1.4 Billion citizens.</a:t>
             </a:r>
-            <a:endParaRPr lang="en-US" sz="1300" dirty="0"/>
-          </a:p>
-        </p:txBody>
-      </p:sp>
-      <p:sp>
-        <p:nvSpPr>
-          <p:cNvPr id="14" name="Shape 12"/>
+            <a:endParaRPr lang="en-US" sz="1250" dirty="0"/>
+          </a:p>
+        </p:txBody>
+      </p:sp>
+      <p:sp>
+        <p:nvSpPr>
+          <p:cNvPr id="14" name="Text 12"/>
+          <p:cNvSpPr/>
+          <p:nvPr/>
+        </p:nvSpPr>
+        <p:spPr>
+          <a:xfrm>
+            <a:off x="914400" y="3154680"/>
+            <a:ext cx="10058400" cy="365760"/>
+          </a:xfrm>
+          <a:prstGeom prst="rect">
+            <a:avLst/>
+          </a:prstGeom>
+          <a:noFill/>
+          <a:ln/>
+        </p:spPr>
+        <p:txBody>
+          <a:bodyPr wrap="square" rtlCol="0" anchor="ctr"/>
+          <a:lstStyle/>
+          <a:p>
+            <a:pPr indent="0" marL="0">
+              <a:buNone/>
+            </a:pPr>
+            <a:r>
+              <a:rPr lang="en-US" sz="1100" b="1" dirty="0">
+                <a:solidFill>
+                  <a:srgbClr val="FF9933"/>
+                </a:solidFill>
+                <a:latin typeface="Arial" pitchFamily="34" charset="0"/>
+                <a:ea typeface="Arial" pitchFamily="34" charset="-122"/>
+                <a:cs typeface="Arial" pitchFamily="34" charset="-120"/>
+              </a:rPr>
+              <a:t>Team Members: Harsh Bhanandari  ·  Tushar Sati  ·  Hairn Bisht  ·  Himani Gargoti  ·  Vinay Joshi  ·  Himanshi Devli</a:t>
+            </a:r>
+            <a:endParaRPr lang="en-US" sz="1100" dirty="0"/>
+          </a:p>
+        </p:txBody>
+      </p:sp>
+      <p:sp>
+        <p:nvSpPr>
+          <p:cNvPr id="15" name="Shape 13"/>
           <p:cNvSpPr/>
           <p:nvPr/>
         </p:nvSpPr>
@@ -2101,7 +2140,7 @@
       </p:sp>
       <p:sp>
         <p:nvSpPr>
-          <p:cNvPr id="15" name="Text 13"/>
+          <p:cNvPr id="16" name="Text 14"/>
           <p:cNvSpPr/>
           <p:nvPr/>
         </p:nvSpPr>
@@ -2140,7 +2179,7 @@
       </p:sp>
       <p:sp>
         <p:nvSpPr>
-          <p:cNvPr id="16" name="Text 14"/>
+          <p:cNvPr id="17" name="Text 15"/>
           <p:cNvSpPr/>
           <p:nvPr/>
         </p:nvSpPr>
@@ -2182,7 +2221,7 @@
       </p:sp>
       <p:sp>
         <p:nvSpPr>
-          <p:cNvPr id="17" name="Shape 15"/>
+          <p:cNvPr id="18" name="Shape 16"/>
           <p:cNvSpPr/>
           <p:nvPr/>
         </p:nvSpPr>
@@ -2209,7 +2248,7 @@
       </p:sp>
       <p:sp>
         <p:nvSpPr>
-          <p:cNvPr id="18" name="Text 16"/>
+          <p:cNvPr id="19" name="Text 17"/>
           <p:cNvSpPr/>
           <p:nvPr/>
         </p:nvSpPr>
@@ -2248,7 +2287,7 @@
       </p:sp>
       <p:sp>
         <p:nvSpPr>
-          <p:cNvPr id="19" name="Text 17"/>
+          <p:cNvPr id="20" name="Text 18"/>
           <p:cNvSpPr/>
           <p:nvPr/>
         </p:nvSpPr>
@@ -2290,7 +2329,7 @@
       </p:sp>
       <p:sp>
         <p:nvSpPr>
-          <p:cNvPr id="20" name="Shape 18"/>
+          <p:cNvPr id="21" name="Shape 19"/>
           <p:cNvSpPr/>
           <p:nvPr/>
         </p:nvSpPr>
@@ -2317,7 +2356,7 @@
       </p:sp>
       <p:sp>
         <p:nvSpPr>
-          <p:cNvPr id="21" name="Text 19"/>
+          <p:cNvPr id="22" name="Text 20"/>
           <p:cNvSpPr/>
           <p:nvPr/>
         </p:nvSpPr>
@@ -2356,7 +2395,7 @@
       </p:sp>
       <p:sp>
         <p:nvSpPr>
-          <p:cNvPr id="22" name="Text 20"/>
+          <p:cNvPr id="23" name="Text 21"/>
           <p:cNvSpPr/>
           <p:nvPr/>
         </p:nvSpPr>
@@ -2398,7 +2437,7 @@
       </p:sp>
       <p:sp>
         <p:nvSpPr>
-          <p:cNvPr id="23" name="Shape 21"/>
+          <p:cNvPr id="24" name="Shape 22"/>
           <p:cNvSpPr/>
           <p:nvPr/>
         </p:nvSpPr>
@@ -2425,7 +2464,7 @@
       </p:sp>
       <p:sp>
         <p:nvSpPr>
-          <p:cNvPr id="24" name="Text 22"/>
+          <p:cNvPr id="25" name="Text 23"/>
           <p:cNvSpPr/>
           <p:nvPr/>
         </p:nvSpPr>
@@ -2464,7 +2503,7 @@
       </p:sp>
       <p:sp>
         <p:nvSpPr>
-          <p:cNvPr id="25" name="Text 23"/>
+          <p:cNvPr id="26" name="Text 24"/>
           <p:cNvSpPr/>
           <p:nvPr/>
         </p:nvSpPr>
@@ -3539,12 +3578,78 @@
         </p:nvSpPr>
         <p:spPr>
           <a:xfrm>
-            <a:off x="548640" y="4846320"/>
-            <a:ext cx="11064240" cy="1280160"/>
+            <a:off x="548640" y="4800600"/>
+            <a:ext cx="11064240" cy="685800"/>
           </a:xfrm>
           <a:prstGeom prst="roundRect">
             <a:avLst>
-              <a:gd name="adj" fmla="val 8571"/>
+              <a:gd name="adj" fmla="val 10667"/>
+            </a:avLst>
+          </a:prstGeom>
+          <a:solidFill>
+            <a:srgbClr val="FFFFFF"/>
+          </a:solidFill>
+          <a:ln w="12700">
+            <a:solidFill>
+              <a:srgbClr val="CBD5E1"/>
+            </a:solidFill>
+            <a:prstDash val="solid"/>
+          </a:ln>
+        </p:spPr>
+      </p:sp>
+      <p:sp>
+        <p:nvSpPr>
+          <p:cNvPr id="24" name="Text 22"/>
+          <p:cNvSpPr/>
+          <p:nvPr/>
+        </p:nvSpPr>
+        <p:spPr>
+          <a:xfrm>
+            <a:off x="731520" y="4919472"/>
+            <a:ext cx="10698480" cy="411480"/>
+          </a:xfrm>
+          <a:prstGeom prst="rect">
+            <a:avLst/>
+          </a:prstGeom>
+          <a:noFill/>
+          <a:ln/>
+        </p:spPr>
+        <p:txBody>
+          <a:bodyPr wrap="square" rtlCol="0" anchor="ctr"/>
+          <a:lstStyle/>
+          <a:p>
+            <a:pPr algn="ctr" indent="0" marL="0">
+              <a:buNone/>
+            </a:pPr>
+            <a:r>
+              <a:rPr lang="en-US" sz="1100" b="1" dirty="0">
+                <a:solidFill>
+                  <a:srgbClr val="174A56"/>
+                </a:solidFill>
+                <a:latin typeface="Arial" pitchFamily="34" charset="0"/>
+                <a:ea typeface="Arial" pitchFamily="34" charset="-122"/>
+                <a:cs typeface="Arial" pitchFamily="34" charset="-120"/>
+              </a:rPr>
+              <a:t>PROJECT TEAM: Harsh Bhanandari  ·  Tushar Sati  ·  Hairn Bisht  ·  Himani Gargoti  ·  Vinay Joshi  ·  Himanshi Devli</a:t>
+            </a:r>
+            <a:endParaRPr lang="en-US" sz="1100" dirty="0"/>
+          </a:p>
+        </p:txBody>
+      </p:sp>
+      <p:sp>
+        <p:nvSpPr>
+          <p:cNvPr id="25" name="Shape 23"/>
+          <p:cNvSpPr/>
+          <p:nvPr/>
+        </p:nvSpPr>
+        <p:spPr>
+          <a:xfrm>
+            <a:off x="548640" y="5577840"/>
+            <a:ext cx="11064240" cy="777240"/>
+          </a:xfrm>
+          <a:prstGeom prst="roundRect">
+            <a:avLst>
+              <a:gd name="adj" fmla="val 11765"/>
             </a:avLst>
           </a:prstGeom>
           <a:solidFill>
@@ -3555,30 +3660,30 @@
       </p:sp>
       <p:sp>
         <p:nvSpPr>
-          <p:cNvPr id="24" name="Text 22"/>
-          <p:cNvSpPr/>
-          <p:nvPr/>
-        </p:nvSpPr>
-        <p:spPr>
-          <a:xfrm>
-            <a:off x="914400" y="5029200"/>
-            <a:ext cx="7315200" cy="365760"/>
-          </a:xfrm>
-          <a:prstGeom prst="rect">
-            <a:avLst/>
-          </a:prstGeom>
-          <a:noFill/>
-          <a:ln/>
-        </p:spPr>
-        <p:txBody>
-          <a:bodyPr wrap="square" rtlCol="0" anchor="ctr"/>
-          <a:lstStyle/>
-          <a:p>
-            <a:pPr indent="0" marL="0">
-              <a:buNone/>
-            </a:pPr>
-            <a:r>
-              <a:rPr lang="en-US" sz="1800" b="1" dirty="0">
+          <p:cNvPr id="26" name="Text 24"/>
+          <p:cNvSpPr/>
+          <p:nvPr/>
+        </p:nvSpPr>
+        <p:spPr>
+          <a:xfrm>
+            <a:off x="822960" y="5669280"/>
+            <a:ext cx="7315200" cy="320040"/>
+          </a:xfrm>
+          <a:prstGeom prst="rect">
+            <a:avLst/>
+          </a:prstGeom>
+          <a:noFill/>
+          <a:ln/>
+        </p:spPr>
+        <p:txBody>
+          <a:bodyPr wrap="square" rtlCol="0" anchor="ctr"/>
+          <a:lstStyle/>
+          <a:p>
+            <a:pPr indent="0" marL="0">
+              <a:buNone/>
+            </a:pPr>
+            <a:r>
+              <a:rPr lang="en-US" sz="1600" b="1" dirty="0">
                 <a:solidFill>
                   <a:srgbClr val="FFFFFF"/>
                 </a:solidFill>
@@ -3588,36 +3693,36 @@
               </a:rPr>
               <a:t>Thank You, Respected Panel Members</a:t>
             </a:r>
-            <a:endParaRPr lang="en-US" sz="1800" dirty="0"/>
-          </a:p>
-        </p:txBody>
-      </p:sp>
-      <p:sp>
-        <p:nvSpPr>
-          <p:cNvPr id="25" name="Text 23"/>
-          <p:cNvSpPr/>
-          <p:nvPr/>
-        </p:nvSpPr>
-        <p:spPr>
-          <a:xfrm>
-            <a:off x="914400" y="5486400"/>
-            <a:ext cx="7315200" cy="457200"/>
-          </a:xfrm>
-          <a:prstGeom prst="rect">
-            <a:avLst/>
-          </a:prstGeom>
-          <a:noFill/>
-          <a:ln/>
-        </p:spPr>
-        <p:txBody>
-          <a:bodyPr wrap="square" rtlCol="0" anchor="ctr"/>
-          <a:lstStyle/>
-          <a:p>
-            <a:pPr indent="0" marL="0">
-              <a:buNone/>
-            </a:pPr>
-            <a:r>
-              <a:rPr lang="en-US" sz="1100" dirty="0">
+            <a:endParaRPr lang="en-US" sz="1600" dirty="0"/>
+          </a:p>
+        </p:txBody>
+      </p:sp>
+      <p:sp>
+        <p:nvSpPr>
+          <p:cNvPr id="27" name="Text 25"/>
+          <p:cNvSpPr/>
+          <p:nvPr/>
+        </p:nvSpPr>
+        <p:spPr>
+          <a:xfrm>
+            <a:off x="822960" y="5989320"/>
+            <a:ext cx="7315200" cy="292608"/>
+          </a:xfrm>
+          <a:prstGeom prst="rect">
+            <a:avLst/>
+          </a:prstGeom>
+          <a:noFill/>
+          <a:ln/>
+        </p:spPr>
+        <p:txBody>
+          <a:bodyPr wrap="square" rtlCol="0" anchor="ctr"/>
+          <a:lstStyle/>
+          <a:p>
+            <a:pPr indent="0" marL="0">
+              <a:buNone/>
+            </a:pPr>
+            <a:r>
+              <a:rPr lang="en-US" sz="1000" dirty="0">
                 <a:solidFill>
                   <a:srgbClr val="E2E8F0"/>
                 </a:solidFill>
@@ -3627,20 +3732,20 @@
               </a:rPr>
               <a:t>WeatherGPT turns meteorological science into life-saving, everyday decisions for every Indian. Ready for Panel Q&amp;A.</a:t>
             </a:r>
-            <a:endParaRPr lang="en-US" sz="1100" dirty="0"/>
-          </a:p>
-        </p:txBody>
-      </p:sp>
-      <p:sp>
-        <p:nvSpPr>
-          <p:cNvPr id="26" name="Text 24"/>
-          <p:cNvSpPr/>
-          <p:nvPr/>
-        </p:nvSpPr>
-        <p:spPr>
-          <a:xfrm>
-            <a:off x="8686800" y="5212080"/>
-            <a:ext cx="2743200" cy="457200"/>
+            <a:endParaRPr lang="en-US" sz="1000" dirty="0"/>
+          </a:p>
+        </p:txBody>
+      </p:sp>
+      <p:sp>
+        <p:nvSpPr>
+          <p:cNvPr id="28" name="Text 26"/>
+          <p:cNvSpPr/>
+          <p:nvPr/>
+        </p:nvSpPr>
+        <p:spPr>
+          <a:xfrm>
+            <a:off x="8686800" y="5715000"/>
+            <a:ext cx="2743200" cy="411480"/>
           </a:xfrm>
           <a:prstGeom prst="rect">
             <a:avLst/>
@@ -3656,7 +3761,7 @@
               <a:buNone/>
             </a:pPr>
             <a:r>
-              <a:rPr lang="en-US" sz="1600" b="1" dirty="0">
+              <a:rPr lang="en-US" sz="1500" b="1" dirty="0">
                 <a:solidFill>
                   <a:srgbClr val="FF9933"/>
                 </a:solidFill>
@@ -3666,7 +3771,7 @@
               </a:rPr>
               <a:t>Q &amp; A SESSION</a:t>
             </a:r>
-            <a:endParaRPr lang="en-US" sz="1600" dirty="0"/>
+            <a:endParaRPr lang="en-US" sz="1500" dirty="0"/>
           </a:p>
         </p:txBody>
       </p:sp>

</xml_diff>